<commit_message>
and that;'s on period
</commit_message>
<xml_diff>
--- a/Homework_1_Template.pptx
+++ b/Homework_1_Template.pptx
@@ -34,7 +34,7 @@
       <p:boldItalic r:id="rId20"/>
     </p:embeddedFont>
     <p:embeddedFont>
-      <p:font typeface="PT Sans Narrow" panose="020B0506020203020204" pitchFamily="34" charset="77"/>
+      <p:font typeface="PT Sans Narrow" panose="020B0506020203020204" pitchFamily="34" charset="0"/>
       <p:regular r:id="rId21"/>
       <p:bold r:id="rId22"/>
     </p:embeddedFont>
@@ -11228,7 +11228,7 @@
           <p:nvPr>
             <p:extLst>
               <p:ext uri="{D42A27DB-BD31-4B8C-83A1-F6EECF244321}">
-                <p14:modId xmlns:p14="http://schemas.microsoft.com/office/powerpoint/2010/main" val="743891218"/>
+                <p14:modId xmlns:p14="http://schemas.microsoft.com/office/powerpoint/2010/main" val="2830297536"/>
               </p:ext>
             </p:extLst>
           </p:nvPr>
@@ -11476,7 +11476,765 @@
                     <a:bodyPr/>
                     <a:lstStyle/>
                     <a:p>
-                      <a:endParaRPr lang="en-US" dirty="0"/>
+                      <a:r>
+                        <a:rPr lang="en-US" sz="800" b="0" i="0" u="none" strike="noStrike" cap="none" dirty="0" err="1">
+                          <a:solidFill>
+                            <a:srgbClr val="000000"/>
+                          </a:solidFill>
+                          <a:effectLst/>
+                          <a:latin typeface="+mn-lt"/>
+                          <a:ea typeface="+mn-ea"/>
+                          <a:cs typeface="+mn-cs"/>
+                          <a:sym typeface="Arial"/>
+                        </a:rPr>
+                        <a:t>lorraine</a:t>
+                      </a:r>
+                      <a:r>
+                        <a:rPr lang="en-US" sz="800" b="0" i="0" u="none" strike="noStrike" cap="none" dirty="0">
+                          <a:solidFill>
+                            <a:srgbClr val="000000"/>
+                          </a:solidFill>
+                          <a:effectLst/>
+                          <a:latin typeface="+mn-lt"/>
+                          <a:ea typeface="+mn-ea"/>
+                          <a:cs typeface="+mn-cs"/>
+                          <a:sym typeface="Arial"/>
+                        </a:rPr>
+                        <a:t> </a:t>
+                      </a:r>
+                      <a:r>
+                        <a:rPr lang="en-US" sz="800" b="0" i="0" u="none" strike="noStrike" cap="none" dirty="0" err="1">
+                          <a:solidFill>
+                            <a:srgbClr val="000000"/>
+                          </a:solidFill>
+                          <a:effectLst/>
+                          <a:latin typeface="+mn-lt"/>
+                          <a:ea typeface="+mn-ea"/>
+                          <a:cs typeface="+mn-cs"/>
+                          <a:sym typeface="Arial"/>
+                        </a:rPr>
+                        <a:t>lorraine</a:t>
+                      </a:r>
+                      <a:r>
+                        <a:rPr lang="en-US" sz="800" b="0" i="0" u="none" strike="noStrike" cap="none" dirty="0">
+                          <a:solidFill>
+                            <a:srgbClr val="000000"/>
+                          </a:solidFill>
+                          <a:effectLst/>
+                          <a:latin typeface="+mn-lt"/>
+                          <a:ea typeface="+mn-ea"/>
+                          <a:cs typeface="+mn-cs"/>
+                          <a:sym typeface="Arial"/>
+                        </a:rPr>
+                        <a:t>, basset </a:t>
+                      </a:r>
+                      <a:r>
+                        <a:rPr lang="en-US" sz="800" b="0" i="0" u="none" strike="noStrike" cap="none" dirty="0" err="1">
+                          <a:solidFill>
+                            <a:srgbClr val="000000"/>
+                          </a:solidFill>
+                          <a:effectLst/>
+                          <a:latin typeface="+mn-lt"/>
+                          <a:ea typeface="+mn-ea"/>
+                          <a:cs typeface="+mn-cs"/>
+                          <a:sym typeface="Arial"/>
+                        </a:rPr>
+                        <a:t>chim</a:t>
+                      </a:r>
+                      <a:r>
+                        <a:rPr lang="en-US" sz="800" b="0" i="0" u="none" strike="noStrike" cap="none" dirty="0">
+                          <a:solidFill>
+                            <a:srgbClr val="000000"/>
+                          </a:solidFill>
+                          <a:effectLst/>
+                          <a:latin typeface="+mn-lt"/>
+                          <a:ea typeface="+mn-ea"/>
+                          <a:cs typeface="+mn-cs"/>
+                          <a:sym typeface="Arial"/>
+                        </a:rPr>
+                        <a:t> </a:t>
+                      </a:r>
+                      <a:r>
+                        <a:rPr lang="en-US" sz="800" b="0" i="0" u="none" strike="noStrike" cap="none" dirty="0" err="1">
+                          <a:solidFill>
+                            <a:srgbClr val="000000"/>
+                          </a:solidFill>
+                          <a:effectLst/>
+                          <a:latin typeface="+mn-lt"/>
+                          <a:ea typeface="+mn-ea"/>
+                          <a:cs typeface="+mn-cs"/>
+                          <a:sym typeface="Arial"/>
+                        </a:rPr>
+                        <a:t>chim</a:t>
+                      </a:r>
+                      <a:r>
+                        <a:rPr lang="en-US" sz="800" b="0" i="0" u="none" strike="noStrike" cap="none" dirty="0">
+                          <a:solidFill>
+                            <a:srgbClr val="000000"/>
+                          </a:solidFill>
+                          <a:effectLst/>
+                          <a:latin typeface="+mn-lt"/>
+                          <a:ea typeface="+mn-ea"/>
+                          <a:cs typeface="+mn-cs"/>
+                          <a:sym typeface="Arial"/>
+                        </a:rPr>
+                        <a:t> </a:t>
+                      </a:r>
+                      <a:r>
+                        <a:rPr lang="en-US" sz="800" b="0" i="0" u="none" strike="noStrike" cap="none" dirty="0" err="1">
+                          <a:solidFill>
+                            <a:srgbClr val="000000"/>
+                          </a:solidFill>
+                          <a:effectLst/>
+                          <a:latin typeface="+mn-lt"/>
+                          <a:ea typeface="+mn-ea"/>
+                          <a:cs typeface="+mn-cs"/>
+                          <a:sym typeface="Arial"/>
+                        </a:rPr>
+                        <a:t>chim</a:t>
+                      </a:r>
+                      <a:r>
+                        <a:rPr lang="en-US" sz="800" b="0" i="0" u="none" strike="noStrike" cap="none" dirty="0">
+                          <a:solidFill>
+                            <a:srgbClr val="000000"/>
+                          </a:solidFill>
+                          <a:effectLst/>
+                          <a:latin typeface="+mn-lt"/>
+                          <a:ea typeface="+mn-ea"/>
+                          <a:cs typeface="+mn-cs"/>
+                          <a:sym typeface="Arial"/>
+                        </a:rPr>
+                        <a:t> - </a:t>
+                      </a:r>
+                      <a:r>
+                        <a:rPr lang="en-US" sz="800" b="0" i="0" u="none" strike="noStrike" cap="none" dirty="0" err="1">
+                          <a:solidFill>
+                            <a:srgbClr val="000000"/>
+                          </a:solidFill>
+                          <a:effectLst/>
+                          <a:latin typeface="+mn-lt"/>
+                          <a:ea typeface="+mn-ea"/>
+                          <a:cs typeface="+mn-cs"/>
+                          <a:sym typeface="Arial"/>
+                        </a:rPr>
+                        <a:t>syracuse</a:t>
+                      </a:r>
+                      <a:r>
+                        <a:rPr lang="en-US" sz="800" b="0" i="0" u="none" strike="noStrike" cap="none" dirty="0">
+                          <a:solidFill>
+                            <a:srgbClr val="000000"/>
+                          </a:solidFill>
+                          <a:effectLst/>
+                          <a:latin typeface="+mn-lt"/>
+                          <a:ea typeface="+mn-ea"/>
+                          <a:cs typeface="+mn-cs"/>
+                          <a:sym typeface="Arial"/>
+                        </a:rPr>
+                        <a:t> </a:t>
+                      </a:r>
+                      <a:r>
+                        <a:rPr lang="en-US" sz="800" b="0" i="0" u="none" strike="noStrike" cap="none" dirty="0" err="1">
+                          <a:solidFill>
+                            <a:srgbClr val="000000"/>
+                          </a:solidFill>
+                          <a:effectLst/>
+                          <a:latin typeface="+mn-lt"/>
+                          <a:ea typeface="+mn-ea"/>
+                          <a:cs typeface="+mn-cs"/>
+                          <a:sym typeface="Arial"/>
+                        </a:rPr>
+                        <a:t>volumnia</a:t>
+                      </a:r>
+                      <a:r>
+                        <a:rPr lang="en-US" sz="800" b="0" i="0" u="none" strike="noStrike" cap="none" dirty="0">
+                          <a:solidFill>
+                            <a:srgbClr val="000000"/>
+                          </a:solidFill>
+                          <a:effectLst/>
+                          <a:latin typeface="+mn-lt"/>
+                          <a:ea typeface="+mn-ea"/>
+                          <a:cs typeface="+mn-cs"/>
+                          <a:sym typeface="Arial"/>
+                        </a:rPr>
+                        <a:t> : is the world, and my lord, </a:t>
+                      </a:r>
+                      <a:r>
+                        <a:rPr lang="en-US" sz="800" b="0" i="0" u="none" strike="noStrike" cap="none" dirty="0" err="1">
+                          <a:solidFill>
+                            <a:srgbClr val="000000"/>
+                          </a:solidFill>
+                          <a:effectLst/>
+                          <a:latin typeface="+mn-lt"/>
+                          <a:ea typeface="+mn-ea"/>
+                          <a:cs typeface="+mn-cs"/>
+                          <a:sym typeface="Arial"/>
+                        </a:rPr>
+                        <a:t>i</a:t>
+                      </a:r>
+                      <a:r>
+                        <a:rPr lang="en-US" sz="800" b="0" i="0" u="none" strike="noStrike" cap="none" dirty="0">
+                          <a:solidFill>
+                            <a:srgbClr val="000000"/>
+                          </a:solidFill>
+                          <a:effectLst/>
+                          <a:latin typeface="+mn-lt"/>
+                          <a:ea typeface="+mn-ea"/>
+                          <a:cs typeface="+mn-cs"/>
+                          <a:sym typeface="Arial"/>
+                        </a:rPr>
+                        <a:t> ' </a:t>
+                      </a:r>
+                      <a:r>
+                        <a:rPr lang="en-US" sz="800" b="0" i="0" u="none" strike="noStrike" cap="none" dirty="0" err="1">
+                          <a:solidFill>
+                            <a:srgbClr val="000000"/>
+                          </a:solidFill>
+                          <a:effectLst/>
+                          <a:latin typeface="+mn-lt"/>
+                          <a:ea typeface="+mn-ea"/>
+                          <a:cs typeface="+mn-cs"/>
+                          <a:sym typeface="Arial"/>
+                        </a:rPr>
+                        <a:t>ll</a:t>
+                      </a:r>
+                      <a:r>
+                        <a:rPr lang="en-US" sz="800" b="0" i="0" u="none" strike="noStrike" cap="none" dirty="0">
+                          <a:solidFill>
+                            <a:srgbClr val="000000"/>
+                          </a:solidFill>
+                          <a:effectLst/>
+                          <a:latin typeface="+mn-lt"/>
+                          <a:ea typeface="+mn-ea"/>
+                          <a:cs typeface="+mn-cs"/>
+                          <a:sym typeface="Arial"/>
+                        </a:rPr>
+                        <a:t> be a man, </a:t>
+                      </a:r>
+                      <a:r>
+                        <a:rPr lang="en-US" sz="800" b="0" i="0" u="none" strike="noStrike" cap="none" dirty="0" err="1">
+                          <a:solidFill>
+                            <a:srgbClr val="000000"/>
+                          </a:solidFill>
+                          <a:effectLst/>
+                          <a:latin typeface="+mn-lt"/>
+                          <a:ea typeface="+mn-ea"/>
+                          <a:cs typeface="+mn-cs"/>
+                          <a:sym typeface="Arial"/>
+                        </a:rPr>
+                        <a:t>volumnia</a:t>
+                      </a:r>
+                      <a:r>
+                        <a:rPr lang="en-US" sz="800" b="0" i="0" u="none" strike="noStrike" cap="none" dirty="0">
+                          <a:solidFill>
+                            <a:srgbClr val="000000"/>
+                          </a:solidFill>
+                          <a:effectLst/>
+                          <a:latin typeface="+mn-lt"/>
+                          <a:ea typeface="+mn-ea"/>
+                          <a:cs typeface="+mn-cs"/>
+                          <a:sym typeface="Arial"/>
+                        </a:rPr>
+                        <a:t> : and </a:t>
+                      </a:r>
+                      <a:r>
+                        <a:rPr lang="en-US" sz="800" b="0" i="0" u="none" strike="noStrike" cap="none" dirty="0" err="1">
+                          <a:solidFill>
+                            <a:srgbClr val="000000"/>
+                          </a:solidFill>
+                          <a:effectLst/>
+                          <a:latin typeface="+mn-lt"/>
+                          <a:ea typeface="+mn-ea"/>
+                          <a:cs typeface="+mn-cs"/>
+                          <a:sym typeface="Arial"/>
+                        </a:rPr>
+                        <a:t>i</a:t>
+                      </a:r>
+                      <a:r>
+                        <a:rPr lang="en-US" sz="800" b="0" i="0" u="none" strike="noStrike" cap="none" dirty="0">
+                          <a:solidFill>
+                            <a:srgbClr val="000000"/>
+                          </a:solidFill>
+                          <a:effectLst/>
+                          <a:latin typeface="+mn-lt"/>
+                          <a:ea typeface="+mn-ea"/>
+                          <a:cs typeface="+mn-cs"/>
+                          <a:sym typeface="Arial"/>
+                        </a:rPr>
+                        <a:t> ' </a:t>
+                      </a:r>
+                      <a:r>
+                        <a:rPr lang="en-US" sz="800" b="0" i="0" u="none" strike="noStrike" cap="none" dirty="0" err="1">
+                          <a:solidFill>
+                            <a:srgbClr val="000000"/>
+                          </a:solidFill>
+                          <a:effectLst/>
+                          <a:latin typeface="+mn-lt"/>
+                          <a:ea typeface="+mn-ea"/>
+                          <a:cs typeface="+mn-cs"/>
+                          <a:sym typeface="Arial"/>
+                        </a:rPr>
+                        <a:t>ll</a:t>
+                      </a:r>
+                      <a:r>
+                        <a:rPr lang="en-US" sz="800" b="0" i="0" u="none" strike="noStrike" cap="none" dirty="0">
+                          <a:solidFill>
+                            <a:srgbClr val="000000"/>
+                          </a:solidFill>
+                          <a:effectLst/>
+                          <a:latin typeface="+mn-lt"/>
+                          <a:ea typeface="+mn-ea"/>
+                          <a:cs typeface="+mn-cs"/>
+                          <a:sym typeface="Arial"/>
+                        </a:rPr>
+                        <a:t> be a man, and </a:t>
+                      </a:r>
+                      <a:r>
+                        <a:rPr lang="en-US" sz="800" b="0" i="0" u="none" strike="noStrike" cap="none" dirty="0" err="1">
+                          <a:solidFill>
+                            <a:srgbClr val="000000"/>
+                          </a:solidFill>
+                          <a:effectLst/>
+                          <a:latin typeface="+mn-lt"/>
+                          <a:ea typeface="+mn-ea"/>
+                          <a:cs typeface="+mn-cs"/>
+                          <a:sym typeface="Arial"/>
+                        </a:rPr>
+                        <a:t>i</a:t>
+                      </a:r>
+                      <a:r>
+                        <a:rPr lang="en-US" sz="800" b="0" i="0" u="none" strike="noStrike" cap="none" dirty="0">
+                          <a:solidFill>
+                            <a:srgbClr val="000000"/>
+                          </a:solidFill>
+                          <a:effectLst/>
+                          <a:latin typeface="+mn-lt"/>
+                          <a:ea typeface="+mn-ea"/>
+                          <a:cs typeface="+mn-cs"/>
+                          <a:sym typeface="Arial"/>
+                        </a:rPr>
+                        <a:t> ' </a:t>
+                      </a:r>
+                      <a:r>
+                        <a:rPr lang="en-US" sz="800" b="0" i="0" u="none" strike="noStrike" cap="none" dirty="0" err="1">
+                          <a:solidFill>
+                            <a:srgbClr val="000000"/>
+                          </a:solidFill>
+                          <a:effectLst/>
+                          <a:latin typeface="+mn-lt"/>
+                          <a:ea typeface="+mn-ea"/>
+                          <a:cs typeface="+mn-cs"/>
+                          <a:sym typeface="Arial"/>
+                        </a:rPr>
+                        <a:t>ll</a:t>
+                      </a:r>
+                      <a:r>
+                        <a:rPr lang="en-US" sz="800" b="0" i="0" u="none" strike="noStrike" cap="none" dirty="0">
+                          <a:solidFill>
+                            <a:srgbClr val="000000"/>
+                          </a:solidFill>
+                          <a:effectLst/>
+                          <a:latin typeface="+mn-lt"/>
+                          <a:ea typeface="+mn-ea"/>
+                          <a:cs typeface="+mn-cs"/>
+                          <a:sym typeface="Arial"/>
+                        </a:rPr>
+                        <a:t> be a man, </a:t>
+                      </a:r>
+                      <a:r>
+                        <a:rPr lang="en-US" sz="800" b="0" i="0" u="none" strike="noStrike" cap="none" dirty="0" err="1">
+                          <a:solidFill>
+                            <a:srgbClr val="000000"/>
+                          </a:solidFill>
+                          <a:effectLst/>
+                          <a:latin typeface="+mn-lt"/>
+                          <a:ea typeface="+mn-ea"/>
+                          <a:cs typeface="+mn-cs"/>
+                          <a:sym typeface="Arial"/>
+                        </a:rPr>
+                        <a:t>volumnia</a:t>
+                      </a:r>
+                      <a:r>
+                        <a:rPr lang="en-US" sz="800" b="0" i="0" u="none" strike="noStrike" cap="none" dirty="0">
+                          <a:solidFill>
+                            <a:srgbClr val="000000"/>
+                          </a:solidFill>
+                          <a:effectLst/>
+                          <a:latin typeface="+mn-lt"/>
+                          <a:ea typeface="+mn-ea"/>
+                          <a:cs typeface="+mn-cs"/>
+                          <a:sym typeface="Arial"/>
+                        </a:rPr>
+                        <a:t> : and </a:t>
+                      </a:r>
+                      <a:r>
+                        <a:rPr lang="en-US" sz="800" b="0" i="0" u="none" strike="noStrike" cap="none" dirty="0" err="1">
+                          <a:solidFill>
+                            <a:srgbClr val="000000"/>
+                          </a:solidFill>
+                          <a:effectLst/>
+                          <a:latin typeface="+mn-lt"/>
+                          <a:ea typeface="+mn-ea"/>
+                          <a:cs typeface="+mn-cs"/>
+                          <a:sym typeface="Arial"/>
+                        </a:rPr>
+                        <a:t>i</a:t>
+                      </a:r>
+                      <a:r>
+                        <a:rPr lang="en-US" sz="800" b="0" i="0" u="none" strike="noStrike" cap="none" dirty="0">
+                          <a:solidFill>
+                            <a:srgbClr val="000000"/>
+                          </a:solidFill>
+                          <a:effectLst/>
+                          <a:latin typeface="+mn-lt"/>
+                          <a:ea typeface="+mn-ea"/>
+                          <a:cs typeface="+mn-cs"/>
+                          <a:sym typeface="Arial"/>
+                        </a:rPr>
+                        <a:t> ' </a:t>
+                      </a:r>
+                      <a:r>
+                        <a:rPr lang="en-US" sz="800" b="0" i="0" u="none" strike="noStrike" cap="none" dirty="0" err="1">
+                          <a:solidFill>
+                            <a:srgbClr val="000000"/>
+                          </a:solidFill>
+                          <a:effectLst/>
+                          <a:latin typeface="+mn-lt"/>
+                          <a:ea typeface="+mn-ea"/>
+                          <a:cs typeface="+mn-cs"/>
+                          <a:sym typeface="Arial"/>
+                        </a:rPr>
+                        <a:t>ll</a:t>
+                      </a:r>
+                      <a:r>
+                        <a:rPr lang="en-US" sz="800" b="0" i="0" u="none" strike="noStrike" cap="none" dirty="0">
+                          <a:solidFill>
+                            <a:srgbClr val="000000"/>
+                          </a:solidFill>
+                          <a:effectLst/>
+                          <a:latin typeface="+mn-lt"/>
+                          <a:ea typeface="+mn-ea"/>
+                          <a:cs typeface="+mn-cs"/>
+                          <a:sym typeface="Arial"/>
+                        </a:rPr>
+                        <a:t> be a man, and </a:t>
+                      </a:r>
+                      <a:r>
+                        <a:rPr lang="en-US" sz="800" b="0" i="0" u="none" strike="noStrike" cap="none" dirty="0" err="1">
+                          <a:solidFill>
+                            <a:srgbClr val="000000"/>
+                          </a:solidFill>
+                          <a:effectLst/>
+                          <a:latin typeface="+mn-lt"/>
+                          <a:ea typeface="+mn-ea"/>
+                          <a:cs typeface="+mn-cs"/>
+                          <a:sym typeface="Arial"/>
+                        </a:rPr>
+                        <a:t>i</a:t>
+                      </a:r>
+                      <a:r>
+                        <a:rPr lang="en-US" sz="800" b="0" i="0" u="none" strike="noStrike" cap="none" dirty="0">
+                          <a:solidFill>
+                            <a:srgbClr val="000000"/>
+                          </a:solidFill>
+                          <a:effectLst/>
+                          <a:latin typeface="+mn-lt"/>
+                          <a:ea typeface="+mn-ea"/>
+                          <a:cs typeface="+mn-cs"/>
+                          <a:sym typeface="Arial"/>
+                        </a:rPr>
+                        <a:t> ' </a:t>
+                      </a:r>
+                      <a:r>
+                        <a:rPr lang="en-US" sz="800" b="0" i="0" u="none" strike="noStrike" cap="none" dirty="0" err="1">
+                          <a:solidFill>
+                            <a:srgbClr val="000000"/>
+                          </a:solidFill>
+                          <a:effectLst/>
+                          <a:latin typeface="+mn-lt"/>
+                          <a:ea typeface="+mn-ea"/>
+                          <a:cs typeface="+mn-cs"/>
+                          <a:sym typeface="Arial"/>
+                        </a:rPr>
+                        <a:t>ll</a:t>
+                      </a:r>
+                      <a:r>
+                        <a:rPr lang="en-US" sz="800" b="0" i="0" u="none" strike="noStrike" cap="none" dirty="0">
+                          <a:solidFill>
+                            <a:srgbClr val="000000"/>
+                          </a:solidFill>
+                          <a:effectLst/>
+                          <a:latin typeface="+mn-lt"/>
+                          <a:ea typeface="+mn-ea"/>
+                          <a:cs typeface="+mn-cs"/>
+                          <a:sym typeface="Arial"/>
+                        </a:rPr>
+                        <a:t> be a man, </a:t>
+                      </a:r>
+                      <a:r>
+                        <a:rPr lang="en-US" sz="800" b="0" i="0" u="none" strike="noStrike" cap="none" dirty="0" err="1">
+                          <a:solidFill>
+                            <a:srgbClr val="000000"/>
+                          </a:solidFill>
+                          <a:effectLst/>
+                          <a:latin typeface="+mn-lt"/>
+                          <a:ea typeface="+mn-ea"/>
+                          <a:cs typeface="+mn-cs"/>
+                          <a:sym typeface="Arial"/>
+                        </a:rPr>
+                        <a:t>volumnia</a:t>
+                      </a:r>
+                      <a:r>
+                        <a:rPr lang="en-US" sz="800" b="0" i="0" u="none" strike="noStrike" cap="none" dirty="0">
+                          <a:solidFill>
+                            <a:srgbClr val="000000"/>
+                          </a:solidFill>
+                          <a:effectLst/>
+                          <a:latin typeface="+mn-lt"/>
+                          <a:ea typeface="+mn-ea"/>
+                          <a:cs typeface="+mn-cs"/>
+                          <a:sym typeface="Arial"/>
+                        </a:rPr>
+                        <a:t> : and </a:t>
+                      </a:r>
+                      <a:r>
+                        <a:rPr lang="en-US" sz="800" b="0" i="0" u="none" strike="noStrike" cap="none" dirty="0" err="1">
+                          <a:solidFill>
+                            <a:srgbClr val="000000"/>
+                          </a:solidFill>
+                          <a:effectLst/>
+                          <a:latin typeface="+mn-lt"/>
+                          <a:ea typeface="+mn-ea"/>
+                          <a:cs typeface="+mn-cs"/>
+                          <a:sym typeface="Arial"/>
+                        </a:rPr>
+                        <a:t>i</a:t>
+                      </a:r>
+                      <a:r>
+                        <a:rPr lang="en-US" sz="800" b="0" i="0" u="none" strike="noStrike" cap="none" dirty="0">
+                          <a:solidFill>
+                            <a:srgbClr val="000000"/>
+                          </a:solidFill>
+                          <a:effectLst/>
+                          <a:latin typeface="+mn-lt"/>
+                          <a:ea typeface="+mn-ea"/>
+                          <a:cs typeface="+mn-cs"/>
+                          <a:sym typeface="Arial"/>
+                        </a:rPr>
+                        <a:t> ' </a:t>
+                      </a:r>
+                      <a:r>
+                        <a:rPr lang="en-US" sz="800" b="0" i="0" u="none" strike="noStrike" cap="none" dirty="0" err="1">
+                          <a:solidFill>
+                            <a:srgbClr val="000000"/>
+                          </a:solidFill>
+                          <a:effectLst/>
+                          <a:latin typeface="+mn-lt"/>
+                          <a:ea typeface="+mn-ea"/>
+                          <a:cs typeface="+mn-cs"/>
+                          <a:sym typeface="Arial"/>
+                        </a:rPr>
+                        <a:t>ll</a:t>
+                      </a:r>
+                      <a:r>
+                        <a:rPr lang="en-US" sz="800" b="0" i="0" u="none" strike="noStrike" cap="none" dirty="0">
+                          <a:solidFill>
+                            <a:srgbClr val="000000"/>
+                          </a:solidFill>
+                          <a:effectLst/>
+                          <a:latin typeface="+mn-lt"/>
+                          <a:ea typeface="+mn-ea"/>
+                          <a:cs typeface="+mn-cs"/>
+                          <a:sym typeface="Arial"/>
+                        </a:rPr>
+                        <a:t> be a man, and </a:t>
+                      </a:r>
+                      <a:r>
+                        <a:rPr lang="en-US" sz="800" b="0" i="0" u="none" strike="noStrike" cap="none" dirty="0" err="1">
+                          <a:solidFill>
+                            <a:srgbClr val="000000"/>
+                          </a:solidFill>
+                          <a:effectLst/>
+                          <a:latin typeface="+mn-lt"/>
+                          <a:ea typeface="+mn-ea"/>
+                          <a:cs typeface="+mn-cs"/>
+                          <a:sym typeface="Arial"/>
+                        </a:rPr>
+                        <a:t>i</a:t>
+                      </a:r>
+                      <a:r>
+                        <a:rPr lang="en-US" sz="800" b="0" i="0" u="none" strike="noStrike" cap="none" dirty="0">
+                          <a:solidFill>
+                            <a:srgbClr val="000000"/>
+                          </a:solidFill>
+                          <a:effectLst/>
+                          <a:latin typeface="+mn-lt"/>
+                          <a:ea typeface="+mn-ea"/>
+                          <a:cs typeface="+mn-cs"/>
+                          <a:sym typeface="Arial"/>
+                        </a:rPr>
+                        <a:t> ' </a:t>
+                      </a:r>
+                      <a:r>
+                        <a:rPr lang="en-US" sz="800" b="0" i="0" u="none" strike="noStrike" cap="none" dirty="0" err="1">
+                          <a:solidFill>
+                            <a:srgbClr val="000000"/>
+                          </a:solidFill>
+                          <a:effectLst/>
+                          <a:latin typeface="+mn-lt"/>
+                          <a:ea typeface="+mn-ea"/>
+                          <a:cs typeface="+mn-cs"/>
+                          <a:sym typeface="Arial"/>
+                        </a:rPr>
+                        <a:t>ll</a:t>
+                      </a:r>
+                      <a:r>
+                        <a:rPr lang="en-US" sz="800" b="0" i="0" u="none" strike="noStrike" cap="none" dirty="0">
+                          <a:solidFill>
+                            <a:srgbClr val="000000"/>
+                          </a:solidFill>
+                          <a:effectLst/>
+                          <a:latin typeface="+mn-lt"/>
+                          <a:ea typeface="+mn-ea"/>
+                          <a:cs typeface="+mn-cs"/>
+                          <a:sym typeface="Arial"/>
+                        </a:rPr>
+                        <a:t> be a man, </a:t>
+                      </a:r>
+                      <a:r>
+                        <a:rPr lang="en-US" sz="800" b="0" i="0" u="none" strike="noStrike" cap="none" dirty="0" err="1">
+                          <a:solidFill>
+                            <a:srgbClr val="000000"/>
+                          </a:solidFill>
+                          <a:effectLst/>
+                          <a:latin typeface="+mn-lt"/>
+                          <a:ea typeface="+mn-ea"/>
+                          <a:cs typeface="+mn-cs"/>
+                          <a:sym typeface="Arial"/>
+                        </a:rPr>
+                        <a:t>volumnia</a:t>
+                      </a:r>
+                      <a:r>
+                        <a:rPr lang="en-US" sz="800" b="0" i="0" u="none" strike="noStrike" cap="none" dirty="0">
+                          <a:solidFill>
+                            <a:srgbClr val="000000"/>
+                          </a:solidFill>
+                          <a:effectLst/>
+                          <a:latin typeface="+mn-lt"/>
+                          <a:ea typeface="+mn-ea"/>
+                          <a:cs typeface="+mn-cs"/>
+                          <a:sym typeface="Arial"/>
+                        </a:rPr>
+                        <a:t> : and </a:t>
+                      </a:r>
+                      <a:r>
+                        <a:rPr lang="en-US" sz="800" b="0" i="0" u="none" strike="noStrike" cap="none" dirty="0" err="1">
+                          <a:solidFill>
+                            <a:srgbClr val="000000"/>
+                          </a:solidFill>
+                          <a:effectLst/>
+                          <a:latin typeface="+mn-lt"/>
+                          <a:ea typeface="+mn-ea"/>
+                          <a:cs typeface="+mn-cs"/>
+                          <a:sym typeface="Arial"/>
+                        </a:rPr>
+                        <a:t>i</a:t>
+                      </a:r>
+                      <a:r>
+                        <a:rPr lang="en-US" sz="800" b="0" i="0" u="none" strike="noStrike" cap="none" dirty="0">
+                          <a:solidFill>
+                            <a:srgbClr val="000000"/>
+                          </a:solidFill>
+                          <a:effectLst/>
+                          <a:latin typeface="+mn-lt"/>
+                          <a:ea typeface="+mn-ea"/>
+                          <a:cs typeface="+mn-cs"/>
+                          <a:sym typeface="Arial"/>
+                        </a:rPr>
+                        <a:t> ' </a:t>
+                      </a:r>
+                      <a:r>
+                        <a:rPr lang="en-US" sz="800" b="0" i="0" u="none" strike="noStrike" cap="none" dirty="0" err="1">
+                          <a:solidFill>
+                            <a:srgbClr val="000000"/>
+                          </a:solidFill>
+                          <a:effectLst/>
+                          <a:latin typeface="+mn-lt"/>
+                          <a:ea typeface="+mn-ea"/>
+                          <a:cs typeface="+mn-cs"/>
+                          <a:sym typeface="Arial"/>
+                        </a:rPr>
+                        <a:t>ll</a:t>
+                      </a:r>
+                      <a:r>
+                        <a:rPr lang="en-US" sz="800" b="0" i="0" u="none" strike="noStrike" cap="none" dirty="0">
+                          <a:solidFill>
+                            <a:srgbClr val="000000"/>
+                          </a:solidFill>
+                          <a:effectLst/>
+                          <a:latin typeface="+mn-lt"/>
+                          <a:ea typeface="+mn-ea"/>
+                          <a:cs typeface="+mn-cs"/>
+                          <a:sym typeface="Arial"/>
+                        </a:rPr>
+                        <a:t> be a man, and </a:t>
+                      </a:r>
+                      <a:r>
+                        <a:rPr lang="en-US" sz="800" b="0" i="0" u="none" strike="noStrike" cap="none" dirty="0" err="1">
+                          <a:solidFill>
+                            <a:srgbClr val="000000"/>
+                          </a:solidFill>
+                          <a:effectLst/>
+                          <a:latin typeface="+mn-lt"/>
+                          <a:ea typeface="+mn-ea"/>
+                          <a:cs typeface="+mn-cs"/>
+                          <a:sym typeface="Arial"/>
+                        </a:rPr>
+                        <a:t>i</a:t>
+                      </a:r>
+                      <a:r>
+                        <a:rPr lang="en-US" sz="800" b="0" i="0" u="none" strike="noStrike" cap="none" dirty="0">
+                          <a:solidFill>
+                            <a:srgbClr val="000000"/>
+                          </a:solidFill>
+                          <a:effectLst/>
+                          <a:latin typeface="+mn-lt"/>
+                          <a:ea typeface="+mn-ea"/>
+                          <a:cs typeface="+mn-cs"/>
+                          <a:sym typeface="Arial"/>
+                        </a:rPr>
+                        <a:t> ' </a:t>
+                      </a:r>
+                      <a:r>
+                        <a:rPr lang="en-US" sz="800" b="0" i="0" u="none" strike="noStrike" cap="none" dirty="0" err="1">
+                          <a:solidFill>
+                            <a:srgbClr val="000000"/>
+                          </a:solidFill>
+                          <a:effectLst/>
+                          <a:latin typeface="+mn-lt"/>
+                          <a:ea typeface="+mn-ea"/>
+                          <a:cs typeface="+mn-cs"/>
+                          <a:sym typeface="Arial"/>
+                        </a:rPr>
+                        <a:t>ll</a:t>
+                      </a:r>
+                      <a:r>
+                        <a:rPr lang="en-US" sz="800" b="0" i="0" u="none" strike="noStrike" cap="none" dirty="0">
+                          <a:solidFill>
+                            <a:srgbClr val="000000"/>
+                          </a:solidFill>
+                          <a:effectLst/>
+                          <a:latin typeface="+mn-lt"/>
+                          <a:ea typeface="+mn-ea"/>
+                          <a:cs typeface="+mn-cs"/>
+                          <a:sym typeface="Arial"/>
+                        </a:rPr>
+                        <a:t> be</a:t>
+                      </a:r>
+                      <a:endParaRPr lang="en-US" sz="800" dirty="0">
+                        <a:solidFill>
+                          <a:srgbClr val="000000"/>
+                        </a:solidFill>
+                      </a:endParaRPr>
                     </a:p>
                   </a:txBody>
                   <a:tcPr/>
@@ -12123,7 +12881,401 @@
                     <a:bodyPr/>
                     <a:lstStyle/>
                     <a:p>
-                      <a:endParaRPr lang="en-US" dirty="0"/>
+                      <a:r>
+                        <a:rPr lang="en-US" sz="800" b="0" i="0" u="none" strike="noStrike" cap="none" dirty="0" err="1">
+                          <a:solidFill>
+                            <a:srgbClr val="000000"/>
+                          </a:solidFill>
+                          <a:effectLst/>
+                          <a:latin typeface="+mn-lt"/>
+                          <a:ea typeface="+mn-ea"/>
+                          <a:cs typeface="+mn-cs"/>
+                          <a:sym typeface="Arial"/>
+                        </a:rPr>
+                        <a:t>lorraine</a:t>
+                      </a:r>
+                      <a:r>
+                        <a:rPr lang="en-US" sz="800" b="0" i="0" u="none" strike="noStrike" cap="none" dirty="0">
+                          <a:solidFill>
+                            <a:srgbClr val="000000"/>
+                          </a:solidFill>
+                          <a:effectLst/>
+                          <a:latin typeface="+mn-lt"/>
+                          <a:ea typeface="+mn-ea"/>
+                          <a:cs typeface="+mn-cs"/>
+                          <a:sym typeface="Arial"/>
+                        </a:rPr>
+                        <a:t>. basset </a:t>
+                      </a:r>
+                      <a:r>
+                        <a:rPr lang="en-US" sz="800" b="0" i="0" u="none" strike="noStrike" cap="none" dirty="0" err="1">
+                          <a:solidFill>
+                            <a:srgbClr val="000000"/>
+                          </a:solidFill>
+                          <a:effectLst/>
+                          <a:latin typeface="+mn-lt"/>
+                          <a:ea typeface="+mn-ea"/>
+                          <a:cs typeface="+mn-cs"/>
+                          <a:sym typeface="Arial"/>
+                        </a:rPr>
+                        <a:t>chim</a:t>
+                      </a:r>
+                      <a:r>
+                        <a:rPr lang="en-US" sz="800" b="0" i="0" u="none" strike="noStrike" cap="none" dirty="0">
+                          <a:solidFill>
+                            <a:srgbClr val="000000"/>
+                          </a:solidFill>
+                          <a:effectLst/>
+                          <a:latin typeface="+mn-lt"/>
+                          <a:ea typeface="+mn-ea"/>
+                          <a:cs typeface="+mn-cs"/>
+                          <a:sym typeface="Arial"/>
+                        </a:rPr>
+                        <a:t> </a:t>
+                      </a:r>
+                      <a:r>
+                        <a:rPr lang="en-US" sz="800" b="0" i="0" u="none" strike="noStrike" cap="none" dirty="0" err="1">
+                          <a:solidFill>
+                            <a:srgbClr val="000000"/>
+                          </a:solidFill>
+                          <a:effectLst/>
+                          <a:latin typeface="+mn-lt"/>
+                          <a:ea typeface="+mn-ea"/>
+                          <a:cs typeface="+mn-cs"/>
+                          <a:sym typeface="Arial"/>
+                        </a:rPr>
+                        <a:t>chim</a:t>
+                      </a:r>
+                      <a:r>
+                        <a:rPr lang="en-US" sz="800" b="0" i="0" u="none" strike="noStrike" cap="none" dirty="0">
+                          <a:solidFill>
+                            <a:srgbClr val="000000"/>
+                          </a:solidFill>
+                          <a:effectLst/>
+                          <a:latin typeface="+mn-lt"/>
+                          <a:ea typeface="+mn-ea"/>
+                          <a:cs typeface="+mn-cs"/>
+                          <a:sym typeface="Arial"/>
+                        </a:rPr>
+                        <a:t> - </a:t>
+                      </a:r>
+                      <a:r>
+                        <a:rPr lang="en-US" sz="800" b="0" i="0" u="none" strike="noStrike" cap="none" dirty="0" err="1">
+                          <a:solidFill>
+                            <a:srgbClr val="000000"/>
+                          </a:solidFill>
+                          <a:effectLst/>
+                          <a:latin typeface="+mn-lt"/>
+                          <a:ea typeface="+mn-ea"/>
+                          <a:cs typeface="+mn-cs"/>
+                          <a:sym typeface="Arial"/>
+                        </a:rPr>
+                        <a:t>moi</a:t>
+                      </a:r>
+                      <a:r>
+                        <a:rPr lang="en-US" sz="800" b="0" i="0" u="none" strike="noStrike" cap="none" dirty="0">
+                          <a:solidFill>
+                            <a:srgbClr val="000000"/>
+                          </a:solidFill>
+                          <a:effectLst/>
+                          <a:latin typeface="+mn-lt"/>
+                          <a:ea typeface="+mn-ea"/>
+                          <a:cs typeface="+mn-cs"/>
+                          <a:sym typeface="Arial"/>
+                        </a:rPr>
+                        <a:t>! snout : sooner, que daughter doth </a:t>
+                      </a:r>
+                      <a:r>
+                        <a:rPr lang="en-US" sz="800" b="0" i="0" u="none" strike="noStrike" cap="none" dirty="0" err="1">
+                          <a:solidFill>
+                            <a:srgbClr val="000000"/>
+                          </a:solidFill>
+                          <a:effectLst/>
+                          <a:latin typeface="+mn-lt"/>
+                          <a:ea typeface="+mn-ea"/>
+                          <a:cs typeface="+mn-cs"/>
+                          <a:sym typeface="Arial"/>
+                        </a:rPr>
+                        <a:t>cymbeline</a:t>
+                      </a:r>
+                      <a:r>
+                        <a:rPr lang="en-US" sz="800" b="0" i="0" u="none" strike="noStrike" cap="none" dirty="0">
+                          <a:solidFill>
+                            <a:srgbClr val="000000"/>
+                          </a:solidFill>
+                          <a:effectLst/>
+                          <a:latin typeface="+mn-lt"/>
+                          <a:ea typeface="+mn-ea"/>
+                          <a:cs typeface="+mn-cs"/>
+                          <a:sym typeface="Arial"/>
+                        </a:rPr>
+                        <a:t> ' s an knowledge ' s old </a:t>
+                      </a:r>
+                      <a:r>
+                        <a:rPr lang="en-US" sz="800" b="0" i="0" u="none" strike="noStrike" cap="none" dirty="0" err="1">
+                          <a:solidFill>
+                            <a:srgbClr val="000000"/>
+                          </a:solidFill>
+                          <a:effectLst/>
+                          <a:latin typeface="+mn-lt"/>
+                          <a:ea typeface="+mn-ea"/>
+                          <a:cs typeface="+mn-cs"/>
+                          <a:sym typeface="Arial"/>
+                        </a:rPr>
+                        <a:t>othello</a:t>
+                      </a:r>
+                      <a:r>
+                        <a:rPr lang="en-US" sz="800" b="0" i="0" u="none" strike="noStrike" cap="none" dirty="0">
+                          <a:solidFill>
+                            <a:srgbClr val="000000"/>
+                          </a:solidFill>
+                          <a:effectLst/>
+                          <a:latin typeface="+mn-lt"/>
+                          <a:ea typeface="+mn-ea"/>
+                          <a:cs typeface="+mn-cs"/>
+                          <a:sym typeface="Arial"/>
+                        </a:rPr>
+                        <a:t> : </a:t>
+                      </a:r>
+                      <a:r>
+                        <a:rPr lang="en-US" sz="800" b="0" i="0" u="none" strike="noStrike" cap="none" dirty="0" err="1">
+                          <a:solidFill>
+                            <a:srgbClr val="000000"/>
+                          </a:solidFill>
+                          <a:effectLst/>
+                          <a:latin typeface="+mn-lt"/>
+                          <a:ea typeface="+mn-ea"/>
+                          <a:cs typeface="+mn-cs"/>
+                          <a:sym typeface="Arial"/>
+                        </a:rPr>
+                        <a:t>dian</a:t>
+                      </a:r>
+                      <a:r>
+                        <a:rPr lang="en-US" sz="800" b="0" i="0" u="none" strike="noStrike" cap="none" dirty="0">
+                          <a:solidFill>
+                            <a:srgbClr val="000000"/>
+                          </a:solidFill>
+                          <a:effectLst/>
+                          <a:latin typeface="+mn-lt"/>
+                          <a:ea typeface="+mn-ea"/>
+                          <a:cs typeface="+mn-cs"/>
+                          <a:sym typeface="Arial"/>
+                        </a:rPr>
+                        <a:t> adder, policy, it as bombast or stick it! </a:t>
+                      </a:r>
+                      <a:r>
+                        <a:rPr lang="en-US" sz="800" b="0" i="0" u="none" strike="noStrike" cap="none" dirty="0" err="1">
+                          <a:solidFill>
+                            <a:srgbClr val="000000"/>
+                          </a:solidFill>
+                          <a:effectLst/>
+                          <a:latin typeface="+mn-lt"/>
+                          <a:ea typeface="+mn-ea"/>
+                          <a:cs typeface="+mn-cs"/>
+                          <a:sym typeface="Arial"/>
+                        </a:rPr>
+                        <a:t>posthumus</a:t>
+                      </a:r>
+                      <a:r>
+                        <a:rPr lang="en-US" sz="800" b="0" i="0" u="none" strike="noStrike" cap="none" dirty="0">
+                          <a:solidFill>
+                            <a:srgbClr val="000000"/>
+                          </a:solidFill>
+                          <a:effectLst/>
+                          <a:latin typeface="+mn-lt"/>
+                          <a:ea typeface="+mn-ea"/>
+                          <a:cs typeface="+mn-cs"/>
+                          <a:sym typeface="Arial"/>
+                        </a:rPr>
+                        <a:t> </a:t>
+                      </a:r>
+                      <a:r>
+                        <a:rPr lang="en-US" sz="800" b="0" i="0" u="none" strike="noStrike" cap="none" dirty="0" err="1">
+                          <a:solidFill>
+                            <a:srgbClr val="000000"/>
+                          </a:solidFill>
+                          <a:effectLst/>
+                          <a:latin typeface="+mn-lt"/>
+                          <a:ea typeface="+mn-ea"/>
+                          <a:cs typeface="+mn-cs"/>
+                          <a:sym typeface="Arial"/>
+                        </a:rPr>
+                        <a:t>leonatus</a:t>
+                      </a:r>
+                      <a:r>
+                        <a:rPr lang="en-US" sz="800" b="0" i="0" u="none" strike="noStrike" cap="none" dirty="0">
+                          <a:solidFill>
+                            <a:srgbClr val="000000"/>
+                          </a:solidFill>
+                          <a:effectLst/>
+                          <a:latin typeface="+mn-lt"/>
+                          <a:ea typeface="+mn-ea"/>
+                          <a:cs typeface="+mn-cs"/>
+                          <a:sym typeface="Arial"/>
+                        </a:rPr>
+                        <a:t> : not where it! mistress page : it is good. </a:t>
+                      </a:r>
+                      <a:r>
+                        <a:rPr lang="en-US" sz="800" b="0" i="0" u="none" strike="noStrike" cap="none" dirty="0" err="1">
+                          <a:solidFill>
+                            <a:srgbClr val="000000"/>
+                          </a:solidFill>
+                          <a:effectLst/>
+                          <a:latin typeface="+mn-lt"/>
+                          <a:ea typeface="+mn-ea"/>
+                          <a:cs typeface="+mn-cs"/>
+                          <a:sym typeface="Arial"/>
+                        </a:rPr>
+                        <a:t>volumnia</a:t>
+                      </a:r>
+                      <a:r>
+                        <a:rPr lang="en-US" sz="800" b="0" i="0" u="none" strike="noStrike" cap="none" dirty="0">
+                          <a:solidFill>
+                            <a:srgbClr val="000000"/>
+                          </a:solidFill>
+                          <a:effectLst/>
+                          <a:latin typeface="+mn-lt"/>
+                          <a:ea typeface="+mn-ea"/>
+                          <a:cs typeface="+mn-cs"/>
+                          <a:sym typeface="Arial"/>
+                        </a:rPr>
+                        <a:t> : [ aside ] </a:t>
+                      </a:r>
+                      <a:r>
+                        <a:rPr lang="en-US" sz="800" b="0" i="0" u="none" strike="noStrike" cap="none" dirty="0" err="1">
+                          <a:solidFill>
+                            <a:srgbClr val="000000"/>
+                          </a:solidFill>
+                          <a:effectLst/>
+                          <a:latin typeface="+mn-lt"/>
+                          <a:ea typeface="+mn-ea"/>
+                          <a:cs typeface="+mn-cs"/>
+                          <a:sym typeface="Arial"/>
+                        </a:rPr>
+                        <a:t>antipholus</a:t>
+                      </a:r>
+                      <a:r>
+                        <a:rPr lang="en-US" sz="800" b="0" i="0" u="none" strike="noStrike" cap="none" dirty="0">
+                          <a:solidFill>
+                            <a:srgbClr val="000000"/>
+                          </a:solidFill>
+                          <a:effectLst/>
+                          <a:latin typeface="+mn-lt"/>
+                          <a:ea typeface="+mn-ea"/>
+                          <a:cs typeface="+mn-cs"/>
+                          <a:sym typeface="Arial"/>
+                        </a:rPr>
+                        <a:t>, faith, </a:t>
+                      </a:r>
+                      <a:r>
+                        <a:rPr lang="en-US" sz="800" b="0" i="0" u="none" strike="noStrike" cap="none" dirty="0" err="1">
+                          <a:solidFill>
+                            <a:srgbClr val="000000"/>
+                          </a:solidFill>
+                          <a:effectLst/>
+                          <a:latin typeface="+mn-lt"/>
+                          <a:ea typeface="+mn-ea"/>
+                          <a:cs typeface="+mn-cs"/>
+                          <a:sym typeface="Arial"/>
+                        </a:rPr>
+                        <a:t>cominius</a:t>
+                      </a:r>
+                      <a:r>
+                        <a:rPr lang="en-US" sz="800" b="0" i="0" u="none" strike="noStrike" cap="none" dirty="0">
+                          <a:solidFill>
+                            <a:srgbClr val="000000"/>
+                          </a:solidFill>
+                          <a:effectLst/>
+                          <a:latin typeface="+mn-lt"/>
+                          <a:ea typeface="+mn-ea"/>
+                          <a:cs typeface="+mn-cs"/>
+                          <a:sym typeface="Arial"/>
+                        </a:rPr>
+                        <a:t> : undertake thou do, if afeard it ghost, </a:t>
+                      </a:r>
+                      <a:r>
+                        <a:rPr lang="en-US" sz="800" b="0" i="0" u="none" strike="noStrike" cap="none" dirty="0" err="1">
+                          <a:solidFill>
+                            <a:srgbClr val="000000"/>
+                          </a:solidFill>
+                          <a:effectLst/>
+                          <a:latin typeface="+mn-lt"/>
+                          <a:ea typeface="+mn-ea"/>
+                          <a:cs typeface="+mn-cs"/>
+                          <a:sym typeface="Arial"/>
+                        </a:rPr>
+                        <a:t>pandarus</a:t>
+                      </a:r>
+                      <a:r>
+                        <a:rPr lang="en-US" sz="800" b="0" i="0" u="none" strike="noStrike" cap="none" dirty="0">
+                          <a:solidFill>
+                            <a:srgbClr val="000000"/>
+                          </a:solidFill>
+                          <a:effectLst/>
+                          <a:latin typeface="+mn-lt"/>
+                          <a:ea typeface="+mn-ea"/>
+                          <a:cs typeface="+mn-cs"/>
+                          <a:sym typeface="Arial"/>
+                        </a:rPr>
+                        <a:t> : when </a:t>
+                      </a:r>
+                      <a:r>
+                        <a:rPr lang="en-US" sz="800" b="0" i="0" u="none" strike="noStrike" cap="none" dirty="0" err="1">
+                          <a:solidFill>
+                            <a:srgbClr val="000000"/>
+                          </a:solidFill>
+                          <a:effectLst/>
+                          <a:latin typeface="+mn-lt"/>
+                          <a:ea typeface="+mn-ea"/>
+                          <a:cs typeface="+mn-cs"/>
+                          <a:sym typeface="Arial"/>
+                        </a:rPr>
+                        <a:t>i</a:t>
+                      </a:r>
+                      <a:r>
+                        <a:rPr lang="en-US" sz="800" b="0" i="0" u="none" strike="noStrike" cap="none" dirty="0">
+                          <a:solidFill>
+                            <a:srgbClr val="000000"/>
+                          </a:solidFill>
+                          <a:effectLst/>
+                          <a:latin typeface="+mn-lt"/>
+                          <a:ea typeface="+mn-ea"/>
+                          <a:cs typeface="+mn-cs"/>
+                          <a:sym typeface="Arial"/>
+                        </a:rPr>
+                        <a:t> be brought thither. bawd : </a:t>
+                      </a:r>
+                      <a:r>
+                        <a:rPr lang="en-US" sz="800" b="0" i="0" u="none" strike="noStrike" cap="none" dirty="0" err="1">
+                          <a:solidFill>
+                            <a:srgbClr val="000000"/>
+                          </a:solidFill>
+                          <a:effectLst/>
+                          <a:latin typeface="+mn-lt"/>
+                          <a:ea typeface="+mn-ea"/>
+                          <a:cs typeface="+mn-cs"/>
+                          <a:sym typeface="Arial"/>
+                        </a:rPr>
+                        <a:t>i</a:t>
+                      </a:r>
+                      <a:r>
+                        <a:rPr lang="en-US" sz="800" b="0" i="0" u="none" strike="noStrike" cap="none" dirty="0">
+                          <a:solidFill>
+                            <a:srgbClr val="000000"/>
+                          </a:solidFill>
+                          <a:effectLst/>
+                          <a:latin typeface="+mn-lt"/>
+                          <a:ea typeface="+mn-ea"/>
+                          <a:cs typeface="+mn-cs"/>
+                          <a:sym typeface="Arial"/>
+                        </a:rPr>
+                        <a:t> wake :' od ' s chance against it, and</a:t>
+                      </a:r>
+                      <a:endParaRPr lang="en-US" sz="800" dirty="0">
+                        <a:solidFill>
+                          <a:srgbClr val="000000"/>
+                        </a:solidFill>
+                      </a:endParaRPr>
                     </a:p>
                   </a:txBody>
                   <a:tcPr/>

</xml_diff>

<commit_message>
update presentation as well
</commit_message>
<xml_diff>
--- a/Homework_1_Template.pptx
+++ b/Homework_1_Template.pptx
@@ -8690,39 +8690,336 @@
         </p:spPr>
         <p:txBody>
           <a:bodyPr spcFirstLastPara="1" wrap="square" lIns="91425" tIns="91425" rIns="91425" bIns="91425" anchor="t" anchorCtr="0">
-            <a:normAutofit/>
+            <a:normAutofit fontScale="55000" lnSpcReduction="20000"/>
           </a:bodyPr>
           <a:lstStyle/>
           <a:p>
-            <a:pPr marL="0" lvl="0" indent="0" algn="l" rtl="0">
+            <a:pPr marL="0" marR="0" lvl="0" indent="0" algn="l" defTabSz="914400" rtl="0" eaLnBrk="1" fontAlgn="auto" latinLnBrk="0" hangingPunct="1">
+              <a:lnSpc>
+                <a:spcPct val="115000"/>
+              </a:lnSpc>
               <a:spcBef>
                 <a:spcPts val="0"/>
               </a:spcBef>
               <a:spcAft>
                 <a:spcPts val="1200"/>
               </a:spcAft>
-              <a:buNone/>
+              <a:buClr>
+                <a:srgbClr val="695D46"/>
+              </a:buClr>
+              <a:buSzPts val="1800"/>
+              <a:buFont typeface="Open Sans"/>
+              <a:buNone/>
+              <a:tabLst/>
+              <a:defRPr/>
             </a:pPr>
             <a:r>
-              <a:rPr lang="en" sz="1400" dirty="0"/>
-              <a:t>Parameters:</a:t>
+              <a:rPr kumimoji="0" lang="en-US" sz="1400" b="0" i="0" u="none" strike="noStrike" kern="0" cap="none" spc="0" normalizeH="0" baseline="0" noProof="0" dirty="0">
+                <a:ln>
+                  <a:noFill/>
+                </a:ln>
+                <a:solidFill>
+                  <a:srgbClr val="695D46"/>
+                </a:solidFill>
+                <a:effectLst/>
+                <a:uLnTx/>
+                <a:uFillTx/>
+                <a:latin typeface="Open Sans"/>
+                <a:ea typeface="Open Sans"/>
+                <a:cs typeface="Open Sans"/>
+                <a:sym typeface="Open Sans"/>
+              </a:rPr>
+              <a:t>optimizer, model type, and parameters)</a:t>
             </a:r>
           </a:p>
           <a:p>
-            <a:pPr marL="0" lvl="0" indent="0" algn="l" rtl="0">
+            <a:pPr marL="0" marR="0" lvl="0" indent="0" algn="l" defTabSz="914400" rtl="0" eaLnBrk="1" fontAlgn="auto" latinLnBrk="0" hangingPunct="1">
+              <a:lnSpc>
+                <a:spcPct val="115000"/>
+              </a:lnSpc>
               <a:spcBef>
                 <a:spcPts val="0"/>
               </a:spcBef>
               <a:spcAft>
                 <a:spcPts val="1200"/>
               </a:spcAft>
-              <a:buNone/>
+              <a:buClr>
+                <a:srgbClr val="695D46"/>
+              </a:buClr>
+              <a:buSzPts val="1800"/>
+              <a:buFont typeface="Open Sans"/>
+              <a:buNone/>
+              <a:tabLst/>
+              <a:defRPr/>
             </a:pPr>
             <a:r>
-              <a:rPr lang="en" sz="1050" dirty="0"/>
-              <a:t>(Include optimizer, model type, and parameters)</a:t>
-            </a:r>
-            <a:endParaRPr sz="1050" dirty="0"/>
+              <a:rPr kumimoji="0" lang="en-US" sz="1400" b="0" i="0" u="none" strike="noStrike" kern="0" cap="none" spc="0" normalizeH="0" baseline="0" noProof="0" dirty="0" err="1">
+                <a:ln>
+                  <a:noFill/>
+                </a:ln>
+                <a:solidFill>
+                  <a:srgbClr val="695D46"/>
+                </a:solidFill>
+                <a:effectLst/>
+                <a:uLnTx/>
+                <a:uFillTx/>
+                <a:latin typeface="Open Sans"/>
+                <a:ea typeface="Open Sans"/>
+                <a:cs typeface="Open Sans"/>
+                <a:sym typeface="Open Sans"/>
+              </a:rPr>
+              <a:t>AdamW</a:t>
+            </a:r>
+            <a:r>
+              <a:rPr kumimoji="0" lang="en-US" sz="1400" b="0" i="0" u="none" strike="noStrike" kern="0" cap="none" spc="0" normalizeH="0" baseline="0" noProof="0" dirty="0">
+                <a:ln>
+                  <a:noFill/>
+                </a:ln>
+                <a:solidFill>
+                  <a:srgbClr val="695D46"/>
+                </a:solidFill>
+                <a:effectLst/>
+                <a:uLnTx/>
+                <a:uFillTx/>
+                <a:latin typeface="Open Sans"/>
+                <a:ea typeface="Open Sans"/>
+                <a:cs typeface="Open Sans"/>
+                <a:sym typeface="Open Sans"/>
+              </a:rPr>
+              <a:t> at 0.01 LR, GRU. </a:t>
+            </a:r>
+          </a:p>
+          <a:p>
+            <a:pPr marL="0" marR="0" lvl="0" indent="0" algn="l" defTabSz="914400" rtl="0" eaLnBrk="1" fontAlgn="auto" latinLnBrk="0" hangingPunct="1">
+              <a:lnSpc>
+                <a:spcPct val="115000"/>
+              </a:lnSpc>
+              <a:spcBef>
+                <a:spcPts val="0"/>
+              </a:spcBef>
+              <a:spcAft>
+                <a:spcPts val="1200"/>
+              </a:spcAft>
+              <a:buClr>
+                <a:srgbClr val="695D46"/>
+              </a:buClr>
+              <a:buSzPts val="1800"/>
+              <a:buFont typeface="Open Sans"/>
+              <a:buNone/>
+              <a:tabLst/>
+              <a:defRPr/>
+            </a:pPr>
+            <a:r>
+              <a:rPr lang="en-US" sz="1400" dirty="0">
+                <a:solidFill>
+                  <a:srgbClr val="695D46"/>
+                </a:solidFill>
+              </a:rPr>
+              <a:t>parameters = Parameters(</a:t>
+            </a:r>
+          </a:p>
+          <a:p>
+            <a:pPr marL="0" marR="0" lvl="0" indent="0" algn="l" defTabSz="914400" rtl="0" eaLnBrk="1" fontAlgn="auto" latinLnBrk="0" hangingPunct="1">
+              <a:lnSpc>
+                <a:spcPct val="115000"/>
+              </a:lnSpc>
+              <a:spcBef>
+                <a:spcPts val="0"/>
+              </a:spcBef>
+              <a:spcAft>
+                <a:spcPts val="1200"/>
+              </a:spcAft>
+              <a:buClr>
+                <a:srgbClr val="695D46"/>
+              </a:buClr>
+              <a:buSzPts val="1800"/>
+              <a:buFont typeface="Open Sans"/>
+              <a:buNone/>
+              <a:tabLst/>
+              <a:defRPr/>
+            </a:pPr>
+            <a:r>
+              <a:rPr lang="en-US" sz="1400" dirty="0">
+                <a:solidFill>
+                  <a:srgbClr val="695D46"/>
+                </a:solidFill>
+              </a:rPr>
+              <a:t>    BATCH_SIZE=32,</a:t>
+            </a:r>
+          </a:p>
+          <a:p>
+            <a:pPr marL="0" marR="0" lvl="0" indent="0" algn="l" defTabSz="914400" rtl="0" eaLnBrk="1" fontAlgn="auto" latinLnBrk="0" hangingPunct="1">
+              <a:lnSpc>
+                <a:spcPct val="115000"/>
+              </a:lnSpc>
+              <a:spcBef>
+                <a:spcPts val="0"/>
+              </a:spcBef>
+              <a:spcAft>
+                <a:spcPts val="1200"/>
+              </a:spcAft>
+              <a:buClr>
+                <a:srgbClr val="695D46"/>
+              </a:buClr>
+              <a:buSzPts val="1800"/>
+              <a:buFont typeface="Open Sans"/>
+              <a:buNone/>
+              <a:tabLst/>
+              <a:defRPr/>
+            </a:pPr>
+            <a:r>
+              <a:rPr lang="en-US" sz="1400" dirty="0">
+                <a:solidFill>
+                  <a:srgbClr val="695D46"/>
+                </a:solidFill>
+              </a:rPr>
+              <a:t>    BPTT=50,</a:t>
+            </a:r>
+          </a:p>
+          <a:p>
+            <a:pPr marL="0" marR="0" lvl="0" indent="0" algn="l" defTabSz="914400" rtl="0" eaLnBrk="1" fontAlgn="auto" latinLnBrk="0" hangingPunct="1">
+              <a:lnSpc>
+                <a:spcPct val="115000"/>
+              </a:lnSpc>
+              <a:spcBef>
+                <a:spcPts val="0"/>
+              </a:spcBef>
+              <a:spcAft>
+                <a:spcPts val="1200"/>
+              </a:spcAft>
+              <a:buClr>
+                <a:srgbClr val="695D46"/>
+              </a:buClr>
+              <a:buSzPts val="1800"/>
+              <a:buFont typeface="Open Sans"/>
+              <a:buNone/>
+              <a:tabLst/>
+              <a:defRPr/>
+            </a:pPr>
+            <a:r>
+              <a:rPr lang="en-US" sz="1400" dirty="0">
+                <a:solidFill>
+                  <a:srgbClr val="695D46"/>
+                </a:solidFill>
+              </a:rPr>
+              <a:t>    LR=0.01,</a:t>
+            </a:r>
+          </a:p>
+          <a:p>
+            <a:pPr marL="0" marR="0" lvl="0" indent="0" algn="l" defTabSz="914400" rtl="0" eaLnBrk="1" fontAlgn="auto" latinLnBrk="0" hangingPunct="1">
+              <a:lnSpc>
+                <a:spcPct val="115000"/>
+              </a:lnSpc>
+              <a:spcBef>
+                <a:spcPts val="0"/>
+              </a:spcBef>
+              <a:spcAft>
+                <a:spcPts val="1200"/>
+              </a:spcAft>
+              <a:buClr>
+                <a:srgbClr val="695D46"/>
+              </a:buClr>
+              <a:buSzPts val="1800"/>
+              <a:buFont typeface="Open Sans"/>
+              <a:buNone/>
+              <a:tabLst/>
+              <a:defRPr/>
+            </a:pPr>
+            <a:r>
+              <a:rPr lang="en-US" sz="1400" dirty="0">
+                <a:solidFill>
+                  <a:srgbClr val="695D46"/>
+                </a:solidFill>
+              </a:rPr>
+              <a:t>    EPOCHS=30,</a:t>
+            </a:r>
+          </a:p>
+          <a:p>
+            <a:pPr marL="0" marR="0" lvl="0" indent="0" algn="l" defTabSz="914400" rtl="0" eaLnBrk="1" fontAlgn="auto" latinLnBrk="0" hangingPunct="1">
+              <a:lnSpc>
+                <a:spcPct val="115000"/>
+              </a:lnSpc>
+              <a:spcBef>
+                <a:spcPts val="0"/>
+              </a:spcBef>
+              <a:spcAft>
+                <a:spcPts val="1200"/>
+              </a:spcAft>
+              <a:buClr>
+                <a:srgbClr val="695D46"/>
+              </a:buClr>
+              <a:buSzPts val="1800"/>
+              <a:buFont typeface="Open Sans"/>
+              <a:buNone/>
+              <a:tabLst/>
+              <a:defRPr/>
+            </a:pPr>
+            <a:r>
+              <a:rPr lang="en-US" sz="1400" dirty="0">
+                <a:solidFill>
+                  <a:srgbClr val="695D46"/>
+                </a:solidFill>
+              </a:rPr>
+              <a:t>    EMBEDDING_DIM=16,</a:t>
+            </a:r>
+          </a:p>
+          <a:p>
+            <a:pPr marL="0" marR="0" lvl="0" indent="0" algn="l" defTabSz="914400" rtl="0" eaLnBrk="1" fontAlgn="auto" latinLnBrk="0" hangingPunct="1">
+              <a:lnSpc>
+                <a:spcPct val="115000"/>
+              </a:lnSpc>
+              <a:spcBef>
+                <a:spcPts val="0"/>
+              </a:spcBef>
+              <a:spcAft>
+                <a:spcPts val="1200"/>
+              </a:spcAft>
+              <a:buClr>
+                <a:srgbClr val="695D46"/>
+              </a:buClr>
+              <a:buSzPts val="1800"/>
+              <a:buFont typeface="Open Sans"/>
+              <a:buNone/>
+              <a:tabLst/>
+              <a:defRPr/>
+            </a:pPr>
+            <a:r>
+              <a:rPr lang="en-US" sz="1400" dirty="0">
+                <a:solidFill>
+                  <a:srgbClr val="695D46"/>
+                </a:solidFill>
+              </a:rPr>
+              <a:t>    HIDDEN_DIM=16,</a:t>
+            </a:r>
+          </a:p>
+          <a:p>
+            <a:pPr marL="0" marR="0" lvl="0" indent="0" algn="l" defTabSz="914400" rtl="0" eaLnBrk="1" fontAlgn="auto" latinLnBrk="0" hangingPunct="1">
+              <a:lnSpc>
+                <a:spcPct val="115000"/>
+              </a:lnSpc>
+              <a:spcBef>
+                <a:spcPts val="0"/>
+              </a:spcBef>
+              <a:spcAft>
+                <a:spcPts val="1200"/>
+              </a:spcAft>
+              <a:buClr>
+                <a:srgbClr val="695D46"/>
+              </a:buClr>
+              <a:buSzPts val="1800"/>
+              <a:buFont typeface="Open Sans"/>
+              <a:buNone/>
+              <a:tabLst/>
+              <a:defRPr/>
+            </a:pPr>
+            <a:r>
+              <a:rPr lang="en-US" sz="1400" dirty="0">
+                <a:solidFill>
+                  <a:srgbClr val="695D46"/>
+                </a:solidFill>
+              </a:rPr>
+              <a:t>    NUM_LAYERS=3, }</a:t>
+            </a:r>
           </a:p>
         </p:txBody>
       </p:sp>
@@ -9421,7 +9718,7 @@
         </p:spPr>
         <p:txBody>
           <a:bodyPr spcFirstLastPara="1" wrap="square" lIns="91425" tIns="91425" rIns="91425" bIns="91425" anchor="t" anchorCtr="0">
-            <a:normAutofit/>
+            <a:noAutofit/>
           </a:bodyPr>
           <a:lstStyle/>
           <a:p>
@@ -9435,7 +9732,7 @@
               <a:buNone/>
             </a:pPr>
             <a:r>
-              <a:rPr lang="en" sz="1400" dirty="0"/>
+              <a:rPr lang="en" sz="800" dirty="0"/>
               <a:t>Parameters:</a:t>
             </a:r>
           </a:p>
@@ -9460,7 +9757,7 @@
               <a:defRPr/>
             </a:pPr>
             <a:r>
-              <a:rPr kumimoji="0" lang="en-US" sz="1050" b="0" i="0" u="none" strike="noStrike" kern="0" cap="none" spc="0" normalizeH="0" baseline="0" noProof="0" dirty="0">
+              <a:rPr kumimoji="0" lang="en-US" sz="800" b="0" i="0" u="none" strike="noStrike" kern="0" cap="none" spc="0" normalizeH="0" baseline="0" noProof="0" dirty="0">
                 <a:ln>
                   <a:noFill/>
                 </a:ln>
@@ -9475,20 +9772,49 @@
                 <a:cs typeface="Open Sans"/>
                 <a:sym typeface="Open Sans"/>
               </a:rPr>
-              <a:t>(Include optimizer, model type, and parameters)</a:t>
-            </a:r>
+              <a:t>(Include</a:t>
+            </a:r>
+            <a:endParaRPr lang="en-US" sz="800" dirty="0">
+              <a:solidFill>
+                <a:srgbClr val="695D46"/>
+              </a:solidFill>
+            </a:endParaRPr>
           </a:p>
           <a:p>
-            <a:pPr marL="0" lvl="0" indent="0" algn="l" rtl="0">
+            <a:pPr marL="0" marR="0" lvl="0" indent="0" algn="l" defTabSz="914400" rtl="0" eaLnBrk="1" fontAlgn="auto" latinLnBrk="0" hangingPunct="1">
+              <a:lnSpc>
+                <a:spcPct val="115000"/>
+              </a:lnSpc>
               <a:spcBef>
                 <a:spcPts val="0"/>
               </a:spcBef>
               <a:spcAft>
                 <a:spcPts val="1200"/>
               </a:spcAft>
-              <a:buNone/>
+              <a:buClr>
+                <a:srgbClr val="695D46"/>
+              </a:buClr>
+              <a:buSzPts val="1800"/>
+              <a:buFont typeface="Open Sans"/>
+              <a:buNone/>
+              <a:tabLst/>
+              <a:defRPr/>
             </a:pPr>
-            <a:endParaRPr sz="1400" dirty="0"/>
+            <a:endParaRPr kumimoji="0" lang="en-US" sz="800" b="0" i="0" u="none" strike="noStrike" kern="0" cap="none" spc="0" normalizeH="0" baseline="0" noProof="0" dirty="0">
+              <a:ln>
+                <a:noFill/>
+              </a:ln>
+              <a:solidFill>
+                <a:srgbClr val="695D46"/>
+              </a:solidFill>
+              <a:effectLst/>
+              <a:uLnTx/>
+              <a:uFillTx/>
+              <a:latin typeface="Open Sans"/>
+              <a:ea typeface="Open Sans"/>
+              <a:cs typeface="Open Sans"/>
+              <a:sym typeface="Open Sans"/>
+            </a:endParaRPr>
           </a:p>
         </p:txBody>
       </p:sp>
@@ -9777,7 +10103,7 @@
             </a:pPr>
             <a:r>
               <a:rPr lang="en" sz="1400" dirty="0"/>
-              <a:t>Explain:</a:t>
+              <a:t>Explain: </a:t>
             </a:r>
             <a:endParaRPr sz="1400" dirty="0"/>
           </a:p>

</xml_diff>